<commit_message>
Fix pitch deck to show graceful precision degradation, not a flat 1.00
The original slide 5 claimed "every one of the top-10 is a genuine
launderer" without qualification -- a bare precision@10 = 1.00 doesn't
survive scrutiny on its own. New chart shows both validation passes
side by side (precision degrading 1.00 -> 0.80 as prevalence drops
21.7% -> 8.8%) plus a prevalence-context panel showing both are still
far above SAML-D's true 0.104% rate. Slide text rewritten to lead with
"degrades gracefully, not collapses" instead of the flat claim.
</commit_message>
<xml_diff>
--- a/assets/AML_Pitch_Deck_v2.pptx
+++ b/assets/AML_Pitch_Deck_v2.pptx
@@ -9,6 +9,7 @@
     <p:sldId id="257" r:id="rId8"/>
     <p:sldId id="258" r:id="rId9"/>
     <p:sldId id="259" r:id="rId10"/>
+    <p:sldId id="260" r:id="rId11"/>
   </p:sldIdLst>
   <p:sldSz cx="12191695" cy="6858000" type="screen4x3"/>
   <p:notesSz cx="6858000" cy="9144000"/>
@@ -3356,7 +3357,7 @@
                 </a:solidFill>
                 <a:latin typeface="Calibri"/>
               </a:rPr>
-              <a:t>1 / 4</a:t>
+              <a:t>1 / 5</a:t>
             </a:r>
           </a:p>
         </p:txBody>
@@ -4264,7 +4265,7 @@
                 </a:solidFill>
                 <a:latin typeface="Calibri"/>
               </a:rPr>
-              <a:t>2 / 4</a:t>
+              <a:t>2 / 5</a:t>
             </a:r>
           </a:p>
         </p:txBody>
@@ -5923,7 +5924,7 @@
                 </a:solidFill>
                 <a:latin typeface="Calibri"/>
               </a:rPr>
-              <a:t>3 / 4</a:t>
+              <a:t>3 / 5</a:t>
             </a:r>
           </a:p>
         </p:txBody>
@@ -7237,7 +7238,7 @@
                 </a:solidFill>
                 <a:latin typeface="Calibri"/>
               </a:rPr>
-              <a:t>4 / 4</a:t>
+              <a:t>4 / 5</a:t>
             </a:r>
           </a:p>
         </p:txBody>
@@ -8415,6 +8416,1039 @@
 </p:sld>
 </file>
 
+<file path=ppt/slides/slide5.xml><?xml version="1.0" encoding="utf-8"?>
+<p:sld xmlns:a="http://schemas.openxmlformats.org/drawingml/2006/main" xmlns:p="http://schemas.openxmlformats.org/presentationml/2006/main" xmlns:r="http://schemas.openxmlformats.org/officeDocument/2006/relationships">
+  <p:cSld>
+    <p:spTree>
+      <p:nvGrpSpPr>
+        <p:cNvPr id="1" name=""/>
+        <p:cNvGrpSpPr/>
+        <p:nvPr/>
+      </p:nvGrpSpPr>
+      <p:grpSpPr/>
+      <p:sp>
+        <p:nvSpPr>
+          <p:cNvPr id="2" name="Rectangle 1"/>
+          <p:cNvSpPr/>
+          <p:nvPr/>
+        </p:nvSpPr>
+        <p:spPr>
+          <a:xfrm>
+            <a:off x="0" y="0"/>
+            <a:ext cx="12191695" cy="960120"/>
+          </a:xfrm>
+          <a:prstGeom prst="rect">
+            <a:avLst/>
+          </a:prstGeom>
+          <a:solidFill>
+            <a:srgbClr val="0F2537"/>
+          </a:solidFill>
+          <a:ln>
+            <a:noFill/>
+          </a:ln>
+          <a:effectLst/>
+        </p:spPr>
+        <p:style>
+          <a:lnRef idx="1">
+            <a:schemeClr val="accent1"/>
+          </a:lnRef>
+          <a:fillRef idx="3">
+            <a:schemeClr val="accent1"/>
+          </a:fillRef>
+          <a:effectRef idx="2">
+            <a:schemeClr val="accent1"/>
+          </a:effectRef>
+          <a:fontRef idx="minor">
+            <a:schemeClr val="lt1"/>
+          </a:fontRef>
+        </p:style>
+        <p:txBody>
+          <a:bodyPr rtlCol="0" anchor="ctr"/>
+          <a:lstStyle/>
+          <a:p>
+            <a:pPr algn="ctr"/>
+          </a:p>
+        </p:txBody>
+      </p:sp>
+      <p:sp>
+        <p:nvSpPr>
+          <p:cNvPr id="3" name="Rectangle 2"/>
+          <p:cNvSpPr/>
+          <p:nvPr/>
+        </p:nvSpPr>
+        <p:spPr>
+          <a:xfrm>
+            <a:off x="0" y="0"/>
+            <a:ext cx="128016" cy="960120"/>
+          </a:xfrm>
+          <a:prstGeom prst="rect">
+            <a:avLst/>
+          </a:prstGeom>
+          <a:solidFill>
+            <a:srgbClr val="1F8A8C"/>
+          </a:solidFill>
+          <a:ln>
+            <a:noFill/>
+          </a:ln>
+          <a:effectLst/>
+        </p:spPr>
+        <p:style>
+          <a:lnRef idx="1">
+            <a:schemeClr val="accent1"/>
+          </a:lnRef>
+          <a:fillRef idx="3">
+            <a:schemeClr val="accent1"/>
+          </a:fillRef>
+          <a:effectRef idx="2">
+            <a:schemeClr val="accent1"/>
+          </a:effectRef>
+          <a:fontRef idx="minor">
+            <a:schemeClr val="lt1"/>
+          </a:fontRef>
+        </p:style>
+        <p:txBody>
+          <a:bodyPr rtlCol="0" anchor="ctr"/>
+          <a:lstStyle/>
+          <a:p>
+            <a:pPr algn="ctr"/>
+          </a:p>
+        </p:txBody>
+      </p:sp>
+      <p:sp>
+        <p:nvSpPr>
+          <p:cNvPr id="4" name="TextBox 3"/>
+          <p:cNvSpPr txBox="1"/>
+          <p:nvPr/>
+        </p:nvSpPr>
+        <p:spPr>
+          <a:xfrm>
+            <a:off x="411480" y="109728"/>
+            <a:ext cx="8503920" cy="777240"/>
+          </a:xfrm>
+          <a:prstGeom prst="rect">
+            <a:avLst/>
+          </a:prstGeom>
+          <a:noFill/>
+        </p:spPr>
+        <p:txBody>
+          <a:bodyPr wrap="square">
+            <a:spAutoFit/>
+          </a:bodyPr>
+          <a:lstStyle/>
+          <a:p>
+            <a:r>
+              <a:rPr sz="2600" b="1">
+                <a:solidFill>
+                  <a:srgbClr val="FFFFFF"/>
+                </a:solidFill>
+                <a:latin typeface="Calibri"/>
+              </a:rPr>
+              <a:t>5 · Real-World Validation &amp; Trust</a:t>
+            </a:r>
+          </a:p>
+        </p:txBody>
+      </p:sp>
+      <p:sp>
+        <p:nvSpPr>
+          <p:cNvPr id="5" name="TextBox 4"/>
+          <p:cNvSpPr txBox="1"/>
+          <p:nvPr/>
+        </p:nvSpPr>
+        <p:spPr>
+          <a:xfrm>
+            <a:off x="8915400" y="146304"/>
+            <a:ext cx="3063240" cy="731520"/>
+          </a:xfrm>
+          <a:prstGeom prst="rect">
+            <a:avLst/>
+          </a:prstGeom>
+          <a:noFill/>
+        </p:spPr>
+        <p:txBody>
+          <a:bodyPr wrap="square">
+            <a:spAutoFit/>
+          </a:bodyPr>
+          <a:lstStyle/>
+          <a:p>
+            <a:pPr algn="r"/>
+            <a:r>
+              <a:rPr sz="1050">
+                <a:solidFill>
+                  <a:srgbClr val="BFD7E8"/>
+                </a:solidFill>
+                <a:latin typeface="Calibri"/>
+              </a:rPr>
+              <a:t>Measured against external data, not just our own synthetic generator</a:t>
+            </a:r>
+          </a:p>
+        </p:txBody>
+      </p:sp>
+      <p:sp>
+        <p:nvSpPr>
+          <p:cNvPr id="6" name="Rectangle 5"/>
+          <p:cNvSpPr/>
+          <p:nvPr/>
+        </p:nvSpPr>
+        <p:spPr>
+          <a:xfrm>
+            <a:off x="365760" y="6528816"/>
+            <a:ext cx="11457432" cy="15240"/>
+          </a:xfrm>
+          <a:prstGeom prst="rect">
+            <a:avLst/>
+          </a:prstGeom>
+          <a:solidFill>
+            <a:srgbClr val="D5DDE4"/>
+          </a:solidFill>
+          <a:ln>
+            <a:noFill/>
+          </a:ln>
+          <a:effectLst/>
+        </p:spPr>
+        <p:style>
+          <a:lnRef idx="1">
+            <a:schemeClr val="accent1"/>
+          </a:lnRef>
+          <a:fillRef idx="3">
+            <a:schemeClr val="accent1"/>
+          </a:fillRef>
+          <a:effectRef idx="2">
+            <a:schemeClr val="accent1"/>
+          </a:effectRef>
+          <a:fontRef idx="minor">
+            <a:schemeClr val="lt1"/>
+          </a:fontRef>
+        </p:style>
+        <p:txBody>
+          <a:bodyPr rtlCol="0" anchor="ctr"/>
+          <a:lstStyle/>
+          <a:p>
+            <a:pPr algn="ctr"/>
+          </a:p>
+        </p:txBody>
+      </p:sp>
+      <p:sp>
+        <p:nvSpPr>
+          <p:cNvPr id="7" name="TextBox 6"/>
+          <p:cNvSpPr txBox="1"/>
+          <p:nvPr/>
+        </p:nvSpPr>
+        <p:spPr>
+          <a:xfrm>
+            <a:off x="365760" y="6565392"/>
+            <a:ext cx="8686800" cy="274320"/>
+          </a:xfrm>
+          <a:prstGeom prst="rect">
+            <a:avLst/>
+          </a:prstGeom>
+          <a:noFill/>
+        </p:spPr>
+        <p:txBody>
+          <a:bodyPr wrap="none">
+            <a:spAutoFit/>
+          </a:bodyPr>
+          <a:lstStyle/>
+          <a:p>
+            <a:r>
+              <a:rPr sz="900">
+                <a:solidFill>
+                  <a:srgbClr val="9AA5B1"/>
+                </a:solidFill>
+                <a:latin typeface="Calibri"/>
+              </a:rPr>
+              <a:t>Multi-Model Anomaly Detection Engine  ·  CDR · Bank · Social</a:t>
+            </a:r>
+          </a:p>
+        </p:txBody>
+      </p:sp>
+      <p:sp>
+        <p:nvSpPr>
+          <p:cNvPr id="8" name="TextBox 7"/>
+          <p:cNvSpPr txBox="1"/>
+          <p:nvPr/>
+        </p:nvSpPr>
+        <p:spPr>
+          <a:xfrm>
+            <a:off x="11247120" y="6565392"/>
+            <a:ext cx="731520" cy="274320"/>
+          </a:xfrm>
+          <a:prstGeom prst="rect">
+            <a:avLst/>
+          </a:prstGeom>
+          <a:noFill/>
+        </p:spPr>
+        <p:txBody>
+          <a:bodyPr wrap="none">
+            <a:spAutoFit/>
+          </a:bodyPr>
+          <a:lstStyle/>
+          <a:p>
+            <a:pPr algn="r"/>
+            <a:r>
+              <a:rPr sz="900">
+                <a:solidFill>
+                  <a:srgbClr val="9AA5B1"/>
+                </a:solidFill>
+                <a:latin typeface="Calibri"/>
+              </a:rPr>
+              <a:t>5 / 5</a:t>
+            </a:r>
+          </a:p>
+        </p:txBody>
+      </p:sp>
+      <p:pic>
+        <p:nvPicPr>
+          <p:cNvPr id="9" name="Picture 8" descr="deck_real_world_validation.png"/>
+          <p:cNvPicPr>
+            <a:picLocks noChangeAspect="1"/>
+          </p:cNvPicPr>
+          <p:nvPr/>
+        </p:nvPicPr>
+        <p:blipFill>
+          <a:blip r:embed="rId2"/>
+          <a:stretch>
+            <a:fillRect/>
+          </a:stretch>
+        </p:blipFill>
+        <p:spPr>
+          <a:xfrm>
+            <a:off x="274320" y="1170432"/>
+            <a:ext cx="6263640" cy="1897907"/>
+          </a:xfrm>
+          <a:prstGeom prst="rect">
+            <a:avLst/>
+          </a:prstGeom>
+        </p:spPr>
+      </p:pic>
+      <p:sp>
+        <p:nvSpPr>
+          <p:cNvPr id="10" name="Rounded Rectangle 9"/>
+          <p:cNvSpPr/>
+          <p:nvPr/>
+        </p:nvSpPr>
+        <p:spPr>
+          <a:xfrm>
+            <a:off x="274320" y="4160520"/>
+            <a:ext cx="6263640" cy="868680"/>
+          </a:xfrm>
+          <a:prstGeom prst="roundRect">
+            <a:avLst>
+              <a:gd name="adj" fmla="val 5500"/>
+            </a:avLst>
+          </a:prstGeom>
+          <a:solidFill>
+            <a:srgbClr val="EAF3EA"/>
+          </a:solidFill>
+          <a:ln w="13970">
+            <a:solidFill>
+              <a:srgbClr val="1F8A8C"/>
+            </a:solidFill>
+          </a:ln>
+          <a:effectLst/>
+        </p:spPr>
+        <p:style>
+          <a:lnRef idx="1">
+            <a:schemeClr val="accent1"/>
+          </a:lnRef>
+          <a:fillRef idx="3">
+            <a:schemeClr val="accent1"/>
+          </a:fillRef>
+          <a:effectRef idx="2">
+            <a:schemeClr val="accent1"/>
+          </a:effectRef>
+          <a:fontRef idx="minor">
+            <a:schemeClr val="lt1"/>
+          </a:fontRef>
+        </p:style>
+        <p:txBody>
+          <a:bodyPr rtlCol="0" anchor="ctr"/>
+          <a:lstStyle/>
+          <a:p>
+            <a:pPr algn="ctr"/>
+          </a:p>
+        </p:txBody>
+      </p:sp>
+      <p:sp>
+        <p:nvSpPr>
+          <p:cNvPr id="11" name="Rectangle 10"/>
+          <p:cNvSpPr/>
+          <p:nvPr/>
+        </p:nvSpPr>
+        <p:spPr>
+          <a:xfrm>
+            <a:off x="274320" y="4251960"/>
+            <a:ext cx="82296" cy="685800"/>
+          </a:xfrm>
+          <a:prstGeom prst="rect">
+            <a:avLst/>
+          </a:prstGeom>
+          <a:solidFill>
+            <a:srgbClr val="1F8A8C"/>
+          </a:solidFill>
+          <a:ln>
+            <a:noFill/>
+          </a:ln>
+          <a:effectLst/>
+        </p:spPr>
+        <p:style>
+          <a:lnRef idx="1">
+            <a:schemeClr val="accent1"/>
+          </a:lnRef>
+          <a:fillRef idx="3">
+            <a:schemeClr val="accent1"/>
+          </a:fillRef>
+          <a:effectRef idx="2">
+            <a:schemeClr val="accent1"/>
+          </a:effectRef>
+          <a:fontRef idx="minor">
+            <a:schemeClr val="lt1"/>
+          </a:fontRef>
+        </p:style>
+        <p:txBody>
+          <a:bodyPr rtlCol="0" anchor="ctr"/>
+          <a:lstStyle/>
+          <a:p>
+            <a:pPr algn="ctr"/>
+          </a:p>
+        </p:txBody>
+      </p:sp>
+      <p:sp>
+        <p:nvSpPr>
+          <p:cNvPr id="12" name="TextBox 11"/>
+          <p:cNvSpPr txBox="1"/>
+          <p:nvPr/>
+        </p:nvSpPr>
+        <p:spPr>
+          <a:xfrm>
+            <a:off x="502920" y="4233672"/>
+            <a:ext cx="5852160" cy="731520"/>
+          </a:xfrm>
+          <a:prstGeom prst="rect">
+            <a:avLst/>
+          </a:prstGeom>
+          <a:noFill/>
+        </p:spPr>
+        <p:txBody>
+          <a:bodyPr wrap="square" lIns="54864" rIns="54864" tIns="18288" bIns="18288">
+            <a:spAutoFit/>
+          </a:bodyPr>
+          <a:lstStyle/>
+          <a:p>
+            <a:pPr algn="l">
+              <a:spcAft>
+                <a:spcPts val="200"/>
+              </a:spcAft>
+            </a:pPr>
+            <a:r>
+              <a:rPr sz="1000" b="1" i="0">
+                <a:solidFill>
+                  <a:srgbClr val="0F2537"/>
+                </a:solidFill>
+                <a:latin typeface="Calibri"/>
+              </a:rPr>
+              <a:t>Precision degrades gracefully, not collapses, as we make the test harder (1.00 → 0.80 @10 as prevalence drops 21.7% → 8.8%) — evidence of real ranking signal on SAML-D (Oztas et al., IEEE ICEBE 2023), never seen during development, not a lucky number at one enriched setting.</a:t>
+            </a:r>
+          </a:p>
+        </p:txBody>
+      </p:sp>
+      <p:sp>
+        <p:nvSpPr>
+          <p:cNvPr id="13" name="Rounded Rectangle 12"/>
+          <p:cNvSpPr/>
+          <p:nvPr/>
+        </p:nvSpPr>
+        <p:spPr>
+          <a:xfrm>
+            <a:off x="274320" y="5166360"/>
+            <a:ext cx="6263640" cy="868680"/>
+          </a:xfrm>
+          <a:prstGeom prst="roundRect">
+            <a:avLst>
+              <a:gd name="adj" fmla="val 5500"/>
+            </a:avLst>
+          </a:prstGeom>
+          <a:solidFill>
+            <a:srgbClr val="FDEEDE"/>
+          </a:solidFill>
+          <a:ln w="13970">
+            <a:solidFill>
+              <a:srgbClr val="E0A03D"/>
+            </a:solidFill>
+          </a:ln>
+          <a:effectLst/>
+        </p:spPr>
+        <p:style>
+          <a:lnRef idx="1">
+            <a:schemeClr val="accent1"/>
+          </a:lnRef>
+          <a:fillRef idx="3">
+            <a:schemeClr val="accent1"/>
+          </a:fillRef>
+          <a:effectRef idx="2">
+            <a:schemeClr val="accent1"/>
+          </a:effectRef>
+          <a:fontRef idx="minor">
+            <a:schemeClr val="lt1"/>
+          </a:fontRef>
+        </p:style>
+        <p:txBody>
+          <a:bodyPr rtlCol="0" anchor="ctr"/>
+          <a:lstStyle/>
+          <a:p>
+            <a:pPr algn="ctr"/>
+          </a:p>
+        </p:txBody>
+      </p:sp>
+      <p:sp>
+        <p:nvSpPr>
+          <p:cNvPr id="14" name="Rectangle 13"/>
+          <p:cNvSpPr/>
+          <p:nvPr/>
+        </p:nvSpPr>
+        <p:spPr>
+          <a:xfrm>
+            <a:off x="274320" y="5257800"/>
+            <a:ext cx="82296" cy="685800"/>
+          </a:xfrm>
+          <a:prstGeom prst="rect">
+            <a:avLst/>
+          </a:prstGeom>
+          <a:solidFill>
+            <a:srgbClr val="E0A03D"/>
+          </a:solidFill>
+          <a:ln>
+            <a:noFill/>
+          </a:ln>
+          <a:effectLst/>
+        </p:spPr>
+        <p:style>
+          <a:lnRef idx="1">
+            <a:schemeClr val="accent1"/>
+          </a:lnRef>
+          <a:fillRef idx="3">
+            <a:schemeClr val="accent1"/>
+          </a:fillRef>
+          <a:effectRef idx="2">
+            <a:schemeClr val="accent1"/>
+          </a:effectRef>
+          <a:fontRef idx="minor">
+            <a:schemeClr val="lt1"/>
+          </a:fontRef>
+        </p:style>
+        <p:txBody>
+          <a:bodyPr rtlCol="0" anchor="ctr"/>
+          <a:lstStyle/>
+          <a:p>
+            <a:pPr algn="ctr"/>
+          </a:p>
+        </p:txBody>
+      </p:sp>
+      <p:sp>
+        <p:nvSpPr>
+          <p:cNvPr id="15" name="TextBox 14"/>
+          <p:cNvSpPr txBox="1"/>
+          <p:nvPr/>
+        </p:nvSpPr>
+        <p:spPr>
+          <a:xfrm>
+            <a:off x="502920" y="5239512"/>
+            <a:ext cx="5852160" cy="731520"/>
+          </a:xfrm>
+          <a:prstGeom prst="rect">
+            <a:avLst/>
+          </a:prstGeom>
+          <a:noFill/>
+        </p:spPr>
+        <p:txBody>
+          <a:bodyPr wrap="square" lIns="54864" rIns="54864" tIns="18288" bIns="18288">
+            <a:spAutoFit/>
+          </a:bodyPr>
+          <a:lstStyle/>
+          <a:p>
+            <a:pPr algn="l">
+              <a:spcAft>
+                <a:spcPts val="200"/>
+              </a:spcAft>
+            </a:pPr>
+            <a:r>
+              <a:rPr sz="1000" b="0" i="0">
+                <a:solidFill>
+                  <a:srgbClr val="0F2537"/>
+                </a:solidFill>
+                <a:latin typeface="Calibri"/>
+              </a:rPr>
+              <a:t>Bonus: real-data validation surfaced two real bugs — a schema-detection gap that silently lost the entity dimension, and a crash-causing infinite recursion in the layering detector — both found and fixed.</a:t>
+            </a:r>
+          </a:p>
+        </p:txBody>
+      </p:sp>
+      <p:sp>
+        <p:nvSpPr>
+          <p:cNvPr id="16" name="Rounded Rectangle 15"/>
+          <p:cNvSpPr/>
+          <p:nvPr/>
+        </p:nvSpPr>
+        <p:spPr>
+          <a:xfrm>
+            <a:off x="6720840" y="1170432"/>
+            <a:ext cx="5166360" cy="2331720"/>
+          </a:xfrm>
+          <a:prstGeom prst="roundRect">
+            <a:avLst>
+              <a:gd name="adj" fmla="val 5500"/>
+            </a:avLst>
+          </a:prstGeom>
+          <a:solidFill>
+            <a:srgbClr val="F4F8FA"/>
+          </a:solidFill>
+          <a:ln w="13970">
+            <a:solidFill>
+              <a:srgbClr val="0F2537"/>
+            </a:solidFill>
+          </a:ln>
+          <a:effectLst/>
+        </p:spPr>
+        <p:style>
+          <a:lnRef idx="1">
+            <a:schemeClr val="accent1"/>
+          </a:lnRef>
+          <a:fillRef idx="3">
+            <a:schemeClr val="accent1"/>
+          </a:fillRef>
+          <a:effectRef idx="2">
+            <a:schemeClr val="accent1"/>
+          </a:effectRef>
+          <a:fontRef idx="minor">
+            <a:schemeClr val="lt1"/>
+          </a:fontRef>
+        </p:style>
+        <p:txBody>
+          <a:bodyPr rtlCol="0" anchor="ctr"/>
+          <a:lstStyle/>
+          <a:p>
+            <a:pPr algn="ctr"/>
+          </a:p>
+        </p:txBody>
+      </p:sp>
+      <p:sp>
+        <p:nvSpPr>
+          <p:cNvPr id="17" name="Rectangle 16"/>
+          <p:cNvSpPr/>
+          <p:nvPr/>
+        </p:nvSpPr>
+        <p:spPr>
+          <a:xfrm>
+            <a:off x="6720840" y="1261872"/>
+            <a:ext cx="82296" cy="2148840"/>
+          </a:xfrm>
+          <a:prstGeom prst="rect">
+            <a:avLst/>
+          </a:prstGeom>
+          <a:solidFill>
+            <a:srgbClr val="0F2537"/>
+          </a:solidFill>
+          <a:ln>
+            <a:noFill/>
+          </a:ln>
+          <a:effectLst/>
+        </p:spPr>
+        <p:style>
+          <a:lnRef idx="1">
+            <a:schemeClr val="accent1"/>
+          </a:lnRef>
+          <a:fillRef idx="3">
+            <a:schemeClr val="accent1"/>
+          </a:fillRef>
+          <a:effectRef idx="2">
+            <a:schemeClr val="accent1"/>
+          </a:effectRef>
+          <a:fontRef idx="minor">
+            <a:schemeClr val="lt1"/>
+          </a:fontRef>
+        </p:style>
+        <p:txBody>
+          <a:bodyPr rtlCol="0" anchor="ctr"/>
+          <a:lstStyle/>
+          <a:p>
+            <a:pPr algn="ctr"/>
+          </a:p>
+        </p:txBody>
+      </p:sp>
+      <p:sp>
+        <p:nvSpPr>
+          <p:cNvPr id="18" name="TextBox 17"/>
+          <p:cNvSpPr txBox="1"/>
+          <p:nvPr/>
+        </p:nvSpPr>
+        <p:spPr>
+          <a:xfrm>
+            <a:off x="6967728" y="1280160"/>
+            <a:ext cx="4709160" cy="2148840"/>
+          </a:xfrm>
+          <a:prstGeom prst="rect">
+            <a:avLst/>
+          </a:prstGeom>
+          <a:noFill/>
+        </p:spPr>
+        <p:txBody>
+          <a:bodyPr wrap="square" lIns="54864" rIns="54864" tIns="18288" bIns="18288">
+            <a:spAutoFit/>
+          </a:bodyPr>
+          <a:lstStyle/>
+          <a:p>
+            <a:pPr algn="l">
+              <a:spcAft>
+                <a:spcPts val="400"/>
+              </a:spcAft>
+            </a:pPr>
+            <a:r>
+              <a:rPr sz="1300" b="1" i="0">
+                <a:solidFill>
+                  <a:srgbClr val="0F2537"/>
+                </a:solidFill>
+                <a:latin typeface="Calibri"/>
+              </a:rPr>
+              <a:t>Legal-basis provenance</a:t>
+            </a:r>
+          </a:p>
+          <a:p>
+            <a:pPr algn="l">
+              <a:spcAft>
+                <a:spcPts val="800"/>
+              </a:spcAft>
+            </a:pPr>
+            <a:r>
+              <a:rPr sz="1050" b="0" i="0">
+                <a:solidFill>
+                  <a:srgbClr val="4A5A6A"/>
+                </a:solidFill>
+                <a:latin typeface="Calibri"/>
+              </a:rPr>
+              <a:t>Every run records who authorized the analysis and under what legal basis (warrant #, case ref, regulatory request) — printed directly into the exported report itself, not hidden metadata.</a:t>
+            </a:r>
+          </a:p>
+          <a:p>
+            <a:pPr algn="l">
+              <a:spcAft>
+                <a:spcPts val="200"/>
+              </a:spcAft>
+            </a:pPr>
+            <a:r>
+              <a:rPr sz="980" b="0" i="1">
+                <a:solidFill>
+                  <a:srgbClr val="4A5A6A"/>
+                </a:solidFill>
+                <a:latin typeface="Calibri"/>
+              </a:rPr>
+              <a:t>“Legal basis / authorization: not recorded” shown honestly when left blank, instead of a fake default — the same never-hide-an-absence discipline as the sufficiency engine.</a:t>
+            </a:r>
+          </a:p>
+        </p:txBody>
+      </p:sp>
+      <p:sp>
+        <p:nvSpPr>
+          <p:cNvPr id="19" name="Rounded Rectangle 18"/>
+          <p:cNvSpPr/>
+          <p:nvPr/>
+        </p:nvSpPr>
+        <p:spPr>
+          <a:xfrm>
+            <a:off x="6720840" y="3657600"/>
+            <a:ext cx="5166360" cy="2377440"/>
+          </a:xfrm>
+          <a:prstGeom prst="roundRect">
+            <a:avLst>
+              <a:gd name="adj" fmla="val 5500"/>
+            </a:avLst>
+          </a:prstGeom>
+          <a:solidFill>
+            <a:srgbClr val="F4F8FA"/>
+          </a:solidFill>
+          <a:ln w="13970">
+            <a:solidFill>
+              <a:srgbClr val="1F8A8C"/>
+            </a:solidFill>
+          </a:ln>
+          <a:effectLst/>
+        </p:spPr>
+        <p:style>
+          <a:lnRef idx="1">
+            <a:schemeClr val="accent1"/>
+          </a:lnRef>
+          <a:fillRef idx="3">
+            <a:schemeClr val="accent1"/>
+          </a:fillRef>
+          <a:effectRef idx="2">
+            <a:schemeClr val="accent1"/>
+          </a:effectRef>
+          <a:fontRef idx="minor">
+            <a:schemeClr val="lt1"/>
+          </a:fontRef>
+        </p:style>
+        <p:txBody>
+          <a:bodyPr rtlCol="0" anchor="ctr"/>
+          <a:lstStyle/>
+          <a:p>
+            <a:pPr algn="ctr"/>
+          </a:p>
+        </p:txBody>
+      </p:sp>
+      <p:sp>
+        <p:nvSpPr>
+          <p:cNvPr id="20" name="Rectangle 19"/>
+          <p:cNvSpPr/>
+          <p:nvPr/>
+        </p:nvSpPr>
+        <p:spPr>
+          <a:xfrm>
+            <a:off x="6720840" y="3749040"/>
+            <a:ext cx="82296" cy="2194560"/>
+          </a:xfrm>
+          <a:prstGeom prst="rect">
+            <a:avLst/>
+          </a:prstGeom>
+          <a:solidFill>
+            <a:srgbClr val="1F8A8C"/>
+          </a:solidFill>
+          <a:ln>
+            <a:noFill/>
+          </a:ln>
+          <a:effectLst/>
+        </p:spPr>
+        <p:style>
+          <a:lnRef idx="1">
+            <a:schemeClr val="accent1"/>
+          </a:lnRef>
+          <a:fillRef idx="3">
+            <a:schemeClr val="accent1"/>
+          </a:fillRef>
+          <a:effectRef idx="2">
+            <a:schemeClr val="accent1"/>
+          </a:effectRef>
+          <a:fontRef idx="minor">
+            <a:schemeClr val="lt1"/>
+          </a:fontRef>
+        </p:style>
+        <p:txBody>
+          <a:bodyPr rtlCol="0" anchor="ctr"/>
+          <a:lstStyle/>
+          <a:p>
+            <a:pPr algn="ctr"/>
+          </a:p>
+        </p:txBody>
+      </p:sp>
+      <p:sp>
+        <p:nvSpPr>
+          <p:cNvPr id="21" name="TextBox 20"/>
+          <p:cNvSpPr txBox="1"/>
+          <p:nvPr/>
+        </p:nvSpPr>
+        <p:spPr>
+          <a:xfrm>
+            <a:off x="6967728" y="3767328"/>
+            <a:ext cx="4709160" cy="2194560"/>
+          </a:xfrm>
+          <a:prstGeom prst="rect">
+            <a:avLst/>
+          </a:prstGeom>
+          <a:noFill/>
+        </p:spPr>
+        <p:txBody>
+          <a:bodyPr wrap="square" lIns="54864" rIns="54864" tIns="18288" bIns="18288">
+            <a:spAutoFit/>
+          </a:bodyPr>
+          <a:lstStyle/>
+          <a:p>
+            <a:pPr algn="l">
+              <a:spcAft>
+                <a:spcPts val="400"/>
+              </a:spcAft>
+            </a:pPr>
+            <a:r>
+              <a:rPr sz="1300" b="1" i="0">
+                <a:solidFill>
+                  <a:srgbClr val="0F2537"/>
+                </a:solidFill>
+                <a:latin typeface="Calibri"/>
+              </a:rPr>
+              <a:t>Chain-of-custody sealing</a:t>
+            </a:r>
+          </a:p>
+          <a:p>
+            <a:pPr algn="l">
+              <a:spcAft>
+                <a:spcPts val="800"/>
+              </a:spcAft>
+            </a:pPr>
+            <a:r>
+              <a:rPr sz="1050" b="0" i="0">
+                <a:solidFill>
+                  <a:srgbClr val="4A5A6A"/>
+                </a:solidFill>
+                <a:latin typeface="Calibri"/>
+              </a:rPr>
+              <a:t>Every archived run is SHA-256 sealed file-by-file and chained to the previous run’s seal — an append-only ledger, live in the app.</a:t>
+            </a:r>
+          </a:p>
+        </p:txBody>
+      </p:sp>
+      <p:sp>
+        <p:nvSpPr>
+          <p:cNvPr id="22" name="Rounded Rectangle 21"/>
+          <p:cNvSpPr/>
+          <p:nvPr/>
+        </p:nvSpPr>
+        <p:spPr>
+          <a:xfrm>
+            <a:off x="6967728" y="5074920"/>
+            <a:ext cx="2331720" cy="384048"/>
+          </a:xfrm>
+          <a:prstGeom prst="roundRect">
+            <a:avLst>
+              <a:gd name="adj" fmla="val 50000"/>
+            </a:avLst>
+          </a:prstGeom>
+          <a:solidFill>
+            <a:srgbClr val="3D9C63"/>
+          </a:solidFill>
+          <a:ln>
+            <a:noFill/>
+          </a:ln>
+          <a:effectLst/>
+        </p:spPr>
+        <p:style>
+          <a:lnRef idx="1">
+            <a:schemeClr val="accent1"/>
+          </a:lnRef>
+          <a:fillRef idx="3">
+            <a:schemeClr val="accent1"/>
+          </a:fillRef>
+          <a:effectRef idx="2">
+            <a:schemeClr val="accent1"/>
+          </a:effectRef>
+          <a:fontRef idx="minor">
+            <a:schemeClr val="lt1"/>
+          </a:fontRef>
+        </p:style>
+        <p:txBody>
+          <a:bodyPr rtlCol="0" anchor="ctr" wrap="none" lIns="18288" rIns="18288"/>
+          <a:lstStyle/>
+          <a:p>
+            <a:pPr algn="ctr"/>
+            <a:r>
+              <a:rPr sz="950" b="1">
+                <a:solidFill>
+                  <a:srgbClr val="FFFFFF"/>
+                </a:solidFill>
+                <a:latin typeface="Calibri"/>
+              </a:rPr>
+              <a:t>Verified: 18/18 match</a:t>
+            </a:r>
+          </a:p>
+        </p:txBody>
+      </p:sp>
+      <p:sp>
+        <p:nvSpPr>
+          <p:cNvPr id="23" name="Rounded Rectangle 22"/>
+          <p:cNvSpPr/>
+          <p:nvPr/>
+        </p:nvSpPr>
+        <p:spPr>
+          <a:xfrm>
+            <a:off x="9418320" y="5074920"/>
+            <a:ext cx="2331720" cy="384048"/>
+          </a:xfrm>
+          <a:prstGeom prst="roundRect">
+            <a:avLst>
+              <a:gd name="adj" fmla="val 50000"/>
+            </a:avLst>
+          </a:prstGeom>
+          <a:solidFill>
+            <a:srgbClr val="C94F4F"/>
+          </a:solidFill>
+          <a:ln>
+            <a:noFill/>
+          </a:ln>
+          <a:effectLst/>
+        </p:spPr>
+        <p:style>
+          <a:lnRef idx="1">
+            <a:schemeClr val="accent1"/>
+          </a:lnRef>
+          <a:fillRef idx="3">
+            <a:schemeClr val="accent1"/>
+          </a:fillRef>
+          <a:effectRef idx="2">
+            <a:schemeClr val="accent1"/>
+          </a:effectRef>
+          <a:fontRef idx="minor">
+            <a:schemeClr val="lt1"/>
+          </a:fontRef>
+        </p:style>
+        <p:txBody>
+          <a:bodyPr rtlCol="0" anchor="ctr" wrap="none" lIns="18288" rIns="18288"/>
+          <a:lstStyle/>
+          <a:p>
+            <a:pPr algn="ctr"/>
+            <a:r>
+              <a:rPr sz="950" b="1">
+                <a:solidFill>
+                  <a:srgbClr val="FFFFFF"/>
+                </a:solidFill>
+                <a:latin typeface="Calibri"/>
+              </a:rPr>
+              <a:t>TAMPERED: report.md</a:t>
+            </a:r>
+          </a:p>
+        </p:txBody>
+      </p:sp>
+      <p:sp>
+        <p:nvSpPr>
+          <p:cNvPr id="24" name="TextBox 23"/>
+          <p:cNvSpPr txBox="1"/>
+          <p:nvPr/>
+        </p:nvSpPr>
+        <p:spPr>
+          <a:xfrm>
+            <a:off x="6967728" y="5532120"/>
+            <a:ext cx="4709160" cy="457200"/>
+          </a:xfrm>
+          <a:prstGeom prst="rect">
+            <a:avLst/>
+          </a:prstGeom>
+          <a:noFill/>
+        </p:spPr>
+        <p:txBody>
+          <a:bodyPr wrap="square" lIns="54864" rIns="54864" tIns="18288" bIns="18288">
+            <a:spAutoFit/>
+          </a:bodyPr>
+          <a:lstStyle/>
+          <a:p>
+            <a:pPr algn="l">
+              <a:spcAft>
+                <a:spcPts val="200"/>
+              </a:spcAft>
+            </a:pPr>
+            <a:r>
+              <a:rPr sz="950" b="0" i="1">
+                <a:solidFill>
+                  <a:srgbClr val="4A5A6A"/>
+                </a:solidFill>
+                <a:latin typeface="Calibri"/>
+              </a:rPr>
+              <a:t>Demoed live via the History dialog’s “Verify integrity” button.</a:t>
+            </a:r>
+          </a:p>
+        </p:txBody>
+      </p:sp>
+    </p:spTree>
+  </p:cSld>
+  <p:clrMapOvr>
+    <a:masterClrMapping/>
+  </p:clrMapOvr>
+</p:sld>
+</file>
+
 <file path=ppt/theme/theme1.xml><?xml version="1.0" encoding="utf-8"?>
 <a:theme xmlns:a="http://schemas.openxmlformats.org/drawingml/2006/main" name="Office Theme">
   <a:themeElements>

</xml_diff>